<commit_message>
cambios presentacion dif aut
</commit_message>
<xml_diff>
--- a/slides/diferenciacion-aut.pptx
+++ b/slides/diferenciacion-aut.pptx
@@ -5,7 +5,7 @@
     <p:sldMasterId id="2147483660" r:id="rId1"/>
   </p:sldMasterIdLst>
   <p:notesMasterIdLst>
-    <p:notesMasterId r:id="rId26"/>
+    <p:notesMasterId r:id="rId27"/>
   </p:notesMasterIdLst>
   <p:sldIdLst>
     <p:sldId id="257" r:id="rId2"/>
@@ -29,9 +29,10 @@
     <p:sldId id="278" r:id="rId20"/>
     <p:sldId id="270" r:id="rId21"/>
     <p:sldId id="280" r:id="rId22"/>
-    <p:sldId id="281" r:id="rId23"/>
-    <p:sldId id="282" r:id="rId24"/>
-    <p:sldId id="283" r:id="rId25"/>
+    <p:sldId id="284" r:id="rId23"/>
+    <p:sldId id="281" r:id="rId24"/>
+    <p:sldId id="282" r:id="rId25"/>
+    <p:sldId id="283" r:id="rId26"/>
   </p:sldIdLst>
   <p:sldSz cx="9144000" cy="5715000" type="screen16x10"/>
   <p:notesSz cx="6858000" cy="9144000"/>
@@ -5609,14 +5610,14 @@
         <a:lstStyle/>
         <a:p>
           <a:r>
-            <a:rPr lang="es-ES_tradnl" b="1"/>
+            <a:rPr lang="es-ES_tradnl" b="1" dirty="0" err="1"/>
             <a:t>PyTorch</a:t>
           </a:r>
           <a:r>
-            <a:rPr lang="es-ES_tradnl"/>
-            <a:t>: Flexibilidad y facilidad de uso. La opción más utilizada en investigación.</a:t>
+            <a:rPr lang="es-ES_tradnl" dirty="0"/>
+            <a:t>: Flexibilidad y facilidad de uso. La opción más utilizada en investigación y en nuevas empresas y nuevos modelos</a:t>
           </a:r>
-          <a:endParaRPr lang="en-US"/>
+          <a:endParaRPr lang="en-US" dirty="0"/>
         </a:p>
       </dgm:t>
     </dgm:pt>
@@ -8229,14 +8230,14 @@
             <a:buNone/>
           </a:pPr>
           <a:r>
-            <a:rPr lang="es-ES_tradnl" sz="1600" b="1" kern="1200"/>
+            <a:rPr lang="es-ES_tradnl" sz="1600" b="1" kern="1200" dirty="0" err="1"/>
             <a:t>PyTorch</a:t>
           </a:r>
           <a:r>
-            <a:rPr lang="es-ES_tradnl" sz="1600" kern="1200"/>
-            <a:t>: Flexibilidad y facilidad de uso. La opción más utilizada en investigación.</a:t>
+            <a:rPr lang="es-ES_tradnl" sz="1600" kern="1200" dirty="0"/>
+            <a:t>: Flexibilidad y facilidad de uso. La opción más utilizada en investigación y en nuevas empresas y nuevos modelos</a:t>
           </a:r>
-          <a:endParaRPr lang="en-US" sz="1600" kern="1200"/>
+          <a:endParaRPr lang="en-US" sz="1600" kern="1200" dirty="0"/>
         </a:p>
       </dsp:txBody>
       <dsp:txXfrm>
@@ -26507,71 +26508,80 @@
           <a:p>
             <a:r>
               <a:rPr lang="es-ES_tradnl" sz="1200" dirty="0"/>
-              <a:t>https://6sense.com/</a:t>
+              <a:t>https://</a:t>
             </a:r>
             <a:r>
               <a:rPr lang="es-ES_tradnl" sz="1200" dirty="0" err="1"/>
-              <a:t>tech</a:t>
+              <a:t>bayelsawatch.com</a:t>
             </a:r>
             <a:r>
               <a:rPr lang="es-ES_tradnl" sz="1200" dirty="0"/>
-              <a:t>/data-</a:t>
-            </a:r>
-            <a:r>
-              <a:rPr lang="es-ES_tradnl" sz="1200" dirty="0" err="1"/>
-              <a:t>science</a:t>
-            </a:r>
-            <a:r>
-              <a:rPr lang="es-ES_tradnl" sz="1200" dirty="0"/>
-              <a:t>-machine-</a:t>
+              <a:t>/machine-</a:t>
             </a:r>
             <a:r>
               <a:rPr lang="es-ES_tradnl" sz="1200" dirty="0" err="1"/>
               <a:t>learning</a:t>
             </a:r>
-            <a:endParaRPr lang="es-ES_tradnl" sz="1200" dirty="0"/>
+            <a:r>
+              <a:rPr lang="es-ES_tradnl" sz="1200" dirty="0"/>
+              <a:t>-</a:t>
+            </a:r>
+            <a:r>
+              <a:rPr lang="es-ES_tradnl" sz="1200" dirty="0" err="1"/>
+              <a:t>statistics</a:t>
+            </a:r>
+            <a:r>
+              <a:rPr lang="es-ES_tradnl" sz="1200" dirty="0"/>
+              <a:t>/</a:t>
+            </a:r>
           </a:p>
         </p:txBody>
       </p:sp>
       <p:pic>
         <p:nvPicPr>
-          <p:cNvPr id="6" name="Imagen 5">
+          <p:cNvPr id="3074" name="Picture 2" descr="Machine Learning Top AI Funding Statistics">
             <a:extLst>
               <a:ext uri="{FF2B5EF4-FFF2-40B4-BE49-F238E27FC236}">
-                <a16:creationId xmlns:a16="http://schemas.microsoft.com/office/drawing/2014/main" id="{011D9BD9-EBC0-CFCF-F9BF-FE4E71C51700}"/>
+                <a16:creationId xmlns:a16="http://schemas.microsoft.com/office/drawing/2014/main" id="{CEDBFBA3-40BC-9162-12F6-E56B4FB4EEAA}"/>
               </a:ext>
             </a:extLst>
           </p:cNvPr>
           <p:cNvPicPr>
-            <a:picLocks noChangeAspect="1"/>
+            <a:picLocks noChangeAspect="1" noChangeArrowheads="1"/>
           </p:cNvPicPr>
           <p:nvPr/>
         </p:nvPicPr>
         <p:blipFill>
           <a:blip r:embed="rId2">
-            <a:clrChange>
-              <a:clrFrom>
-                <a:srgbClr val="FFFFFF"/>
-              </a:clrFrom>
-              <a:clrTo>
-                <a:srgbClr val="FFFFFF">
-                  <a:alpha val="0"/>
-                </a:srgbClr>
-              </a:clrTo>
-            </a:clrChange>
+            <a:extLst>
+              <a:ext uri="{28A0092B-C50C-407E-A947-70E740481C1C}">
+                <a14:useLocalDpi xmlns:a14="http://schemas.microsoft.com/office/drawing/2010/main" val="0"/>
+              </a:ext>
+            </a:extLst>
           </a:blip>
+          <a:srcRect/>
           <a:stretch>
             <a:fillRect/>
           </a:stretch>
         </p:blipFill>
-        <p:spPr>
+        <p:spPr bwMode="auto">
           <a:xfrm>
-            <a:off x="694591" y="1518180"/>
-            <a:ext cx="8159263" cy="4150650"/>
+            <a:off x="987552" y="1799536"/>
+            <a:ext cx="6986016" cy="3120663"/>
           </a:xfrm>
           <a:prstGeom prst="rect">
             <a:avLst/>
           </a:prstGeom>
+          <a:noFill/>
+          <a:extLst>
+            <a:ext uri="{909E8E84-426E-40DD-AFC4-6F175D3DCCD1}">
+              <a14:hiddenFill xmlns:a14="http://schemas.microsoft.com/office/drawing/2010/main">
+                <a:solidFill>
+                  <a:srgbClr val="FFFFFF"/>
+                </a:solidFill>
+              </a14:hiddenFill>
+            </a:ext>
+          </a:extLst>
         </p:spPr>
       </p:pic>
     </p:spTree>
@@ -26600,6 +26610,625 @@
 </file>
 
 <file path=ppt/slides/slide22.xml><?xml version="1.0" encoding="utf-8"?>
+<p:sld xmlns:a="http://schemas.openxmlformats.org/drawingml/2006/main" xmlns:r="http://schemas.openxmlformats.org/officeDocument/2006/relationships" xmlns:p="http://schemas.openxmlformats.org/presentationml/2006/main">
+  <p:cSld>
+    <p:bg>
+      <p:bgPr>
+        <a:solidFill>
+          <a:schemeClr val="bg1"/>
+        </a:solidFill>
+        <a:effectLst/>
+      </p:bgPr>
+    </p:bg>
+    <p:spTree>
+      <p:nvGrpSpPr>
+        <p:cNvPr id="1" name="">
+          <a:extLst>
+            <a:ext uri="{FF2B5EF4-FFF2-40B4-BE49-F238E27FC236}">
+              <a16:creationId xmlns:a16="http://schemas.microsoft.com/office/drawing/2014/main" id="{8D01CE2F-C0C7-62C9-BE91-EF0AF75E4491}"/>
+            </a:ext>
+          </a:extLst>
+        </p:cNvPr>
+        <p:cNvGrpSpPr/>
+        <p:nvPr/>
+      </p:nvGrpSpPr>
+      <p:grpSpPr>
+        <a:xfrm>
+          <a:off x="0" y="0"/>
+          <a:ext cx="0" cy="0"/>
+          <a:chOff x="0" y="0"/>
+          <a:chExt cx="0" cy="0"/>
+        </a:xfrm>
+      </p:grpSpPr>
+      <p:sp useBgFill="1">
+        <p:nvSpPr>
+          <p:cNvPr id="9" name="Rectangle 8">
+            <a:extLst>
+              <a:ext uri="{FF2B5EF4-FFF2-40B4-BE49-F238E27FC236}">
+                <a16:creationId xmlns:a16="http://schemas.microsoft.com/office/drawing/2014/main" id="{5E06BCB7-25F4-480E-9704-B3E113650AF6}"/>
+              </a:ext>
+              <a:ext uri="{C183D7F6-B498-43B3-948B-1728B52AA6E4}">
+                <adec:decorative xmlns:adec="http://schemas.microsoft.com/office/drawing/2017/decorative" val="1"/>
+              </a:ext>
+            </a:extLst>
+          </p:cNvPr>
+          <p:cNvSpPr>
+            <a:spLocks noGrp="1" noRot="1" noChangeAspect="1" noMove="1" noResize="1" noEditPoints="1" noAdjustHandles="1" noChangeArrowheads="1" noChangeShapeType="1" noTextEdit="1"/>
+          </p:cNvSpPr>
+          <p:nvPr>
+            <p:extLst>
+              <p:ext uri="{386F3935-93C4-4BCD-93E2-E3B085C9AB24}">
+                <p16:designElem xmlns:p16="http://schemas.microsoft.com/office/powerpoint/2015/main" val="1"/>
+              </p:ext>
+            </p:extLst>
+          </p:nvPr>
+        </p:nvSpPr>
+        <p:spPr>
+          <a:xfrm>
+            <a:off x="0" y="0"/>
+            <a:ext cx="9144000" cy="5715000"/>
+          </a:xfrm>
+          <a:prstGeom prst="rect">
+            <a:avLst/>
+          </a:prstGeom>
+          <a:ln>
+            <a:noFill/>
+          </a:ln>
+        </p:spPr>
+        <p:style>
+          <a:lnRef idx="2">
+            <a:schemeClr val="accent1">
+              <a:shade val="50000"/>
+            </a:schemeClr>
+          </a:lnRef>
+          <a:fillRef idx="1">
+            <a:schemeClr val="accent1"/>
+          </a:fillRef>
+          <a:effectRef idx="0">
+            <a:schemeClr val="accent1"/>
+          </a:effectRef>
+          <a:fontRef idx="minor">
+            <a:schemeClr val="lt1"/>
+          </a:fontRef>
+        </p:style>
+        <p:txBody>
+          <a:bodyPr rtlCol="0" anchor="ctr"/>
+          <a:lstStyle/>
+          <a:p>
+            <a:pPr algn="ctr"/>
+            <a:endParaRPr lang="en-US"/>
+          </a:p>
+        </p:txBody>
+      </p:sp>
+      <p:sp>
+        <p:nvSpPr>
+          <p:cNvPr id="4" name="CuadroTexto 3">
+            <a:extLst>
+              <a:ext uri="{FF2B5EF4-FFF2-40B4-BE49-F238E27FC236}">
+                <a16:creationId xmlns:a16="http://schemas.microsoft.com/office/drawing/2014/main" id="{74E29AD1-728D-ADB8-589B-5C81C2A687CF}"/>
+              </a:ext>
+            </a:extLst>
+          </p:cNvPr>
+          <p:cNvSpPr txBox="1"/>
+          <p:nvPr/>
+        </p:nvSpPr>
+        <p:spPr>
+          <a:xfrm>
+            <a:off x="479160" y="347980"/>
+            <a:ext cx="8182230" cy="1041161"/>
+          </a:xfrm>
+          <a:prstGeom prst="rect">
+            <a:avLst/>
+          </a:prstGeom>
+        </p:spPr>
+        <p:txBody>
+          <a:bodyPr vert="horz" lIns="91440" tIns="45720" rIns="91440" bIns="45720" rtlCol="0" anchor="ctr">
+            <a:normAutofit/>
+          </a:bodyPr>
+          <a:lstStyle/>
+          <a:p>
+            <a:pPr algn="ctr" defTabSz="914400">
+              <a:lnSpc>
+                <a:spcPct val="90000"/>
+              </a:lnSpc>
+              <a:spcBef>
+                <a:spcPct val="0"/>
+              </a:spcBef>
+              <a:spcAft>
+                <a:spcPts val="600"/>
+              </a:spcAft>
+            </a:pPr>
+            <a:r>
+              <a:rPr lang="en-US" sz="3400" kern="1200" dirty="0" err="1">
+                <a:solidFill>
+                  <a:schemeClr val="tx1"/>
+                </a:solidFill>
+                <a:latin typeface="+mj-lt"/>
+                <a:ea typeface="+mj-ea"/>
+                <a:cs typeface="+mj-cs"/>
+              </a:rPr>
+              <a:t>Tendencia</a:t>
+            </a:r>
+            <a:r>
+              <a:rPr lang="en-US" sz="3400" kern="1200" dirty="0">
+                <a:solidFill>
+                  <a:schemeClr val="tx1"/>
+                </a:solidFill>
+                <a:latin typeface="+mj-lt"/>
+                <a:ea typeface="+mj-ea"/>
+                <a:cs typeface="+mj-cs"/>
+              </a:rPr>
+              <a:t> </a:t>
+            </a:r>
+            <a:r>
+              <a:rPr lang="en-US" sz="3400" kern="1200" dirty="0" err="1">
+                <a:solidFill>
+                  <a:schemeClr val="tx1"/>
+                </a:solidFill>
+                <a:latin typeface="+mj-lt"/>
+                <a:ea typeface="+mj-ea"/>
+                <a:cs typeface="+mj-cs"/>
+              </a:rPr>
+              <a:t>en</a:t>
+            </a:r>
+            <a:r>
+              <a:rPr lang="en-US" sz="3400" kern="1200" dirty="0">
+                <a:solidFill>
+                  <a:schemeClr val="tx1"/>
+                </a:solidFill>
+                <a:latin typeface="+mj-lt"/>
+                <a:ea typeface="+mj-ea"/>
+                <a:cs typeface="+mj-cs"/>
+              </a:rPr>
+              <a:t> la </a:t>
+            </a:r>
+            <a:r>
+              <a:rPr lang="en-US" sz="3400" kern="1200" dirty="0" err="1">
+                <a:solidFill>
+                  <a:schemeClr val="tx1"/>
+                </a:solidFill>
+                <a:latin typeface="+mj-lt"/>
+                <a:ea typeface="+mj-ea"/>
+                <a:cs typeface="+mj-cs"/>
+              </a:rPr>
+              <a:t>industria</a:t>
+            </a:r>
+            <a:endParaRPr lang="en-US" sz="3400" kern="1200" dirty="0">
+              <a:solidFill>
+                <a:schemeClr val="tx1"/>
+              </a:solidFill>
+              <a:latin typeface="+mj-lt"/>
+              <a:ea typeface="+mj-ea"/>
+              <a:cs typeface="+mj-cs"/>
+            </a:endParaRPr>
+          </a:p>
+        </p:txBody>
+      </p:sp>
+      <p:sp>
+        <p:nvSpPr>
+          <p:cNvPr id="11" name="sketch line">
+            <a:extLst>
+              <a:ext uri="{FF2B5EF4-FFF2-40B4-BE49-F238E27FC236}">
+                <a16:creationId xmlns:a16="http://schemas.microsoft.com/office/drawing/2014/main" id="{C71AC33C-AD04-99E6-4434-1E159E2B77D4}"/>
+              </a:ext>
+              <a:ext uri="{C183D7F6-B498-43B3-948B-1728B52AA6E4}">
+                <adec:decorative xmlns:adec="http://schemas.microsoft.com/office/drawing/2017/decorative" val="1"/>
+              </a:ext>
+            </a:extLst>
+          </p:cNvPr>
+          <p:cNvSpPr>
+            <a:spLocks noGrp="1" noRot="1" noChangeAspect="1" noMove="1" noResize="1" noEditPoints="1" noAdjustHandles="1" noChangeArrowheads="1" noChangeShapeType="1" noTextEdit="1"/>
+          </p:cNvSpPr>
+          <p:nvPr>
+            <p:extLst>
+              <p:ext uri="{386F3935-93C4-4BCD-93E2-E3B085C9AB24}">
+                <p16:designElem xmlns:p16="http://schemas.microsoft.com/office/powerpoint/2015/main" val="1"/>
+              </p:ext>
+            </p:extLst>
+          </p:nvPr>
+        </p:nvSpPr>
+        <p:spPr>
+          <a:xfrm>
+            <a:off x="2855776" y="1444545"/>
+            <a:ext cx="3429000" cy="15240"/>
+          </a:xfrm>
+          <a:custGeom>
+            <a:avLst/>
+            <a:gdLst>
+              <a:gd name="csX0" fmla="*/ 0 w 3429000"/>
+              <a:gd name="csY0" fmla="*/ 0 h 15240"/>
+              <a:gd name="csX1" fmla="*/ 685800 w 3429000"/>
+              <a:gd name="csY1" fmla="*/ 0 h 15240"/>
+              <a:gd name="csX2" fmla="*/ 1371600 w 3429000"/>
+              <a:gd name="csY2" fmla="*/ 0 h 15240"/>
+              <a:gd name="csX3" fmla="*/ 2057400 w 3429000"/>
+              <a:gd name="csY3" fmla="*/ 0 h 15240"/>
+              <a:gd name="csX4" fmla="*/ 2674620 w 3429000"/>
+              <a:gd name="csY4" fmla="*/ 0 h 15240"/>
+              <a:gd name="csX5" fmla="*/ 3429000 w 3429000"/>
+              <a:gd name="csY5" fmla="*/ 0 h 15240"/>
+              <a:gd name="csX6" fmla="*/ 3429000 w 3429000"/>
+              <a:gd name="csY6" fmla="*/ 15240 h 15240"/>
+              <a:gd name="csX7" fmla="*/ 2811780 w 3429000"/>
+              <a:gd name="csY7" fmla="*/ 15240 h 15240"/>
+              <a:gd name="csX8" fmla="*/ 2228850 w 3429000"/>
+              <a:gd name="csY8" fmla="*/ 15240 h 15240"/>
+              <a:gd name="csX9" fmla="*/ 1543050 w 3429000"/>
+              <a:gd name="csY9" fmla="*/ 15240 h 15240"/>
+              <a:gd name="csX10" fmla="*/ 925830 w 3429000"/>
+              <a:gd name="csY10" fmla="*/ 15240 h 15240"/>
+              <a:gd name="csX11" fmla="*/ 0 w 3429000"/>
+              <a:gd name="csY11" fmla="*/ 15240 h 15240"/>
+              <a:gd name="csX12" fmla="*/ 0 w 3429000"/>
+              <a:gd name="csY12" fmla="*/ 0 h 15240"/>
+            </a:gdLst>
+            <a:ahLst/>
+            <a:cxnLst>
+              <a:cxn ang="0">
+                <a:pos x="csX0" y="csY0"/>
+              </a:cxn>
+              <a:cxn ang="0">
+                <a:pos x="csX1" y="csY1"/>
+              </a:cxn>
+              <a:cxn ang="0">
+                <a:pos x="csX2" y="csY2"/>
+              </a:cxn>
+              <a:cxn ang="0">
+                <a:pos x="csX3" y="csY3"/>
+              </a:cxn>
+              <a:cxn ang="0">
+                <a:pos x="csX4" y="csY4"/>
+              </a:cxn>
+              <a:cxn ang="0">
+                <a:pos x="csX5" y="csY5"/>
+              </a:cxn>
+              <a:cxn ang="0">
+                <a:pos x="csX6" y="csY6"/>
+              </a:cxn>
+              <a:cxn ang="0">
+                <a:pos x="csX7" y="csY7"/>
+              </a:cxn>
+              <a:cxn ang="0">
+                <a:pos x="csX8" y="csY8"/>
+              </a:cxn>
+              <a:cxn ang="0">
+                <a:pos x="csX9" y="csY9"/>
+              </a:cxn>
+              <a:cxn ang="0">
+                <a:pos x="csX10" y="csY10"/>
+              </a:cxn>
+              <a:cxn ang="0">
+                <a:pos x="csX11" y="csY11"/>
+              </a:cxn>
+              <a:cxn ang="0">
+                <a:pos x="csX12" y="csY12"/>
+              </a:cxn>
+            </a:cxnLst>
+            <a:rect l="l" t="t" r="r" b="b"/>
+            <a:pathLst>
+              <a:path w="3429000" h="15240" fill="none" extrusionOk="0">
+                <a:moveTo>
+                  <a:pt x="0" y="0"/>
+                </a:moveTo>
+                <a:cubicBezTo>
+                  <a:pt x="219865" y="20479"/>
+                  <a:pt x="493281" y="26186"/>
+                  <a:pt x="685800" y="0"/>
+                </a:cubicBezTo>
+                <a:cubicBezTo>
+                  <a:pt x="878319" y="-26186"/>
+                  <a:pt x="1121382" y="-11869"/>
+                  <a:pt x="1371600" y="0"/>
+                </a:cubicBezTo>
+                <a:cubicBezTo>
+                  <a:pt x="1621818" y="11869"/>
+                  <a:pt x="1878793" y="32281"/>
+                  <a:pt x="2057400" y="0"/>
+                </a:cubicBezTo>
+                <a:cubicBezTo>
+                  <a:pt x="2236007" y="-32281"/>
+                  <a:pt x="2433797" y="-18251"/>
+                  <a:pt x="2674620" y="0"/>
+                </a:cubicBezTo>
+                <a:cubicBezTo>
+                  <a:pt x="2915443" y="18251"/>
+                  <a:pt x="3205923" y="-1443"/>
+                  <a:pt x="3429000" y="0"/>
+                </a:cubicBezTo>
+                <a:cubicBezTo>
+                  <a:pt x="3428985" y="7298"/>
+                  <a:pt x="3428935" y="8153"/>
+                  <a:pt x="3429000" y="15240"/>
+                </a:cubicBezTo>
+                <a:cubicBezTo>
+                  <a:pt x="3221081" y="45560"/>
+                  <a:pt x="3088001" y="5018"/>
+                  <a:pt x="2811780" y="15240"/>
+                </a:cubicBezTo>
+                <a:cubicBezTo>
+                  <a:pt x="2535559" y="25462"/>
+                  <a:pt x="2481355" y="21850"/>
+                  <a:pt x="2228850" y="15240"/>
+                </a:cubicBezTo>
+                <a:cubicBezTo>
+                  <a:pt x="1976345" y="8631"/>
+                  <a:pt x="1807520" y="45308"/>
+                  <a:pt x="1543050" y="15240"/>
+                </a:cubicBezTo>
+                <a:cubicBezTo>
+                  <a:pt x="1278580" y="-14828"/>
+                  <a:pt x="1181944" y="2075"/>
+                  <a:pt x="925830" y="15240"/>
+                </a:cubicBezTo>
+                <a:cubicBezTo>
+                  <a:pt x="669716" y="28405"/>
+                  <a:pt x="410304" y="31767"/>
+                  <a:pt x="0" y="15240"/>
+                </a:cubicBezTo>
+                <a:cubicBezTo>
+                  <a:pt x="151" y="8290"/>
+                  <a:pt x="-277" y="5563"/>
+                  <a:pt x="0" y="0"/>
+                </a:cubicBezTo>
+                <a:close/>
+              </a:path>
+              <a:path w="3429000" h="15240" stroke="0" extrusionOk="0">
+                <a:moveTo>
+                  <a:pt x="0" y="0"/>
+                </a:moveTo>
+                <a:cubicBezTo>
+                  <a:pt x="174095" y="-12874"/>
+                  <a:pt x="443087" y="-14090"/>
+                  <a:pt x="617220" y="0"/>
+                </a:cubicBezTo>
+                <a:cubicBezTo>
+                  <a:pt x="791353" y="14090"/>
+                  <a:pt x="1072677" y="8451"/>
+                  <a:pt x="1200150" y="0"/>
+                </a:cubicBezTo>
+                <a:cubicBezTo>
+                  <a:pt x="1327623" y="-8451"/>
+                  <a:pt x="1526638" y="19866"/>
+                  <a:pt x="1817370" y="0"/>
+                </a:cubicBezTo>
+                <a:cubicBezTo>
+                  <a:pt x="2108102" y="-19866"/>
+                  <a:pt x="2221289" y="26161"/>
+                  <a:pt x="2503170" y="0"/>
+                </a:cubicBezTo>
+                <a:cubicBezTo>
+                  <a:pt x="2785051" y="-26161"/>
+                  <a:pt x="3022134" y="39178"/>
+                  <a:pt x="3429000" y="0"/>
+                </a:cubicBezTo>
+                <a:cubicBezTo>
+                  <a:pt x="3429120" y="5894"/>
+                  <a:pt x="3428447" y="9630"/>
+                  <a:pt x="3429000" y="15240"/>
+                </a:cubicBezTo>
+                <a:cubicBezTo>
+                  <a:pt x="3103464" y="-2455"/>
+                  <a:pt x="2887909" y="19892"/>
+                  <a:pt x="2743200" y="15240"/>
+                </a:cubicBezTo>
+                <a:cubicBezTo>
+                  <a:pt x="2598491" y="10588"/>
+                  <a:pt x="2362615" y="7608"/>
+                  <a:pt x="1988820" y="15240"/>
+                </a:cubicBezTo>
+                <a:cubicBezTo>
+                  <a:pt x="1615025" y="22872"/>
+                  <a:pt x="1580494" y="645"/>
+                  <a:pt x="1405890" y="15240"/>
+                </a:cubicBezTo>
+                <a:cubicBezTo>
+                  <a:pt x="1231286" y="29836"/>
+                  <a:pt x="885259" y="-19333"/>
+                  <a:pt x="651510" y="15240"/>
+                </a:cubicBezTo>
+                <a:cubicBezTo>
+                  <a:pt x="417761" y="49813"/>
+                  <a:pt x="138362" y="-16904"/>
+                  <a:pt x="0" y="15240"/>
+                </a:cubicBezTo>
+                <a:cubicBezTo>
+                  <a:pt x="-628" y="8463"/>
+                  <a:pt x="-538" y="6337"/>
+                  <a:pt x="0" y="0"/>
+                </a:cubicBezTo>
+                <a:close/>
+              </a:path>
+            </a:pathLst>
+          </a:custGeom>
+          <a:solidFill>
+            <a:schemeClr val="accent2"/>
+          </a:solidFill>
+          <a:ln w="41275" cap="rnd">
+            <a:solidFill>
+              <a:schemeClr val="accent2"/>
+            </a:solidFill>
+            <a:round/>
+            <a:extLst>
+              <a:ext uri="{C807C97D-BFC1-408E-A445-0C87EB9F89A2}">
+                <ask:lineSketchStyleProps xmlns:ask="http://schemas.microsoft.com/office/drawing/2018/sketchyshapes" sd="2727557108">
+                  <a:prstGeom prst="rect">
+                    <a:avLst/>
+                  </a:prstGeom>
+                  <ask:type>
+                    <ask:lineSketchFreehand/>
+                  </ask:type>
+                </ask:lineSketchStyleProps>
+              </a:ext>
+            </a:extLst>
+          </a:ln>
+        </p:spPr>
+        <p:style>
+          <a:lnRef idx="2">
+            <a:schemeClr val="accent1">
+              <a:shade val="50000"/>
+            </a:schemeClr>
+          </a:lnRef>
+          <a:fillRef idx="1">
+            <a:schemeClr val="accent1"/>
+          </a:fillRef>
+          <a:effectRef idx="0">
+            <a:schemeClr val="accent1"/>
+          </a:effectRef>
+          <a:fontRef idx="minor">
+            <a:schemeClr val="lt1"/>
+          </a:fontRef>
+        </p:style>
+        <p:txBody>
+          <a:bodyPr rtlCol="0" anchor="ctr"/>
+          <a:lstStyle/>
+          <a:p>
+            <a:pPr algn="ctr"/>
+            <a:endParaRPr lang="en-US"/>
+          </a:p>
+        </p:txBody>
+      </p:sp>
+      <p:sp>
+        <p:nvSpPr>
+          <p:cNvPr id="2" name="CuadroTexto 1">
+            <a:extLst>
+              <a:ext uri="{FF2B5EF4-FFF2-40B4-BE49-F238E27FC236}">
+                <a16:creationId xmlns:a16="http://schemas.microsoft.com/office/drawing/2014/main" id="{190457B3-3C7F-350E-46E4-A9BB52776A12}"/>
+              </a:ext>
+            </a:extLst>
+          </p:cNvPr>
+          <p:cNvSpPr txBox="1"/>
+          <p:nvPr/>
+        </p:nvSpPr>
+        <p:spPr>
+          <a:xfrm>
+            <a:off x="5099537" y="5259950"/>
+            <a:ext cx="4246685" cy="276999"/>
+          </a:xfrm>
+          <a:prstGeom prst="rect">
+            <a:avLst/>
+          </a:prstGeom>
+          <a:noFill/>
+        </p:spPr>
+        <p:txBody>
+          <a:bodyPr wrap="square">
+            <a:spAutoFit/>
+          </a:bodyPr>
+          <a:lstStyle/>
+          <a:p>
+            <a:r>
+              <a:rPr lang="es-ES_tradnl" sz="1200" dirty="0"/>
+              <a:t>https://</a:t>
+            </a:r>
+            <a:r>
+              <a:rPr lang="es-ES_tradnl" sz="1200" dirty="0" err="1"/>
+              <a:t>bayelsawatch.com</a:t>
+            </a:r>
+            <a:r>
+              <a:rPr lang="es-ES_tradnl" sz="1200" dirty="0"/>
+              <a:t>/machine-</a:t>
+            </a:r>
+            <a:r>
+              <a:rPr lang="es-ES_tradnl" sz="1200" dirty="0" err="1"/>
+              <a:t>learning</a:t>
+            </a:r>
+            <a:r>
+              <a:rPr lang="es-ES_tradnl" sz="1200" dirty="0"/>
+              <a:t>-</a:t>
+            </a:r>
+            <a:r>
+              <a:rPr lang="es-ES_tradnl" sz="1200" dirty="0" err="1"/>
+              <a:t>statistics</a:t>
+            </a:r>
+            <a:r>
+              <a:rPr lang="es-ES_tradnl" sz="1200" dirty="0"/>
+              <a:t>/</a:t>
+            </a:r>
+          </a:p>
+        </p:txBody>
+      </p:sp>
+      <p:pic>
+        <p:nvPicPr>
+          <p:cNvPr id="5122" name="Picture 2" descr="Top Data Science And Machine Learning Technologies In 2026">
+            <a:extLst>
+              <a:ext uri="{FF2B5EF4-FFF2-40B4-BE49-F238E27FC236}">
+                <a16:creationId xmlns:a16="http://schemas.microsoft.com/office/drawing/2014/main" id="{BD8DBABF-6B4B-DACF-5056-CB3DEA6FFAAC}"/>
+              </a:ext>
+            </a:extLst>
+          </p:cNvPr>
+          <p:cNvPicPr>
+            <a:picLocks noChangeAspect="1" noChangeArrowheads="1"/>
+          </p:cNvPicPr>
+          <p:nvPr/>
+        </p:nvPicPr>
+        <p:blipFill>
+          <a:blip r:embed="rId2">
+            <a:clrChange>
+              <a:clrFrom>
+                <a:srgbClr val="FFFFFF"/>
+              </a:clrFrom>
+              <a:clrTo>
+                <a:srgbClr val="FFFFFF">
+                  <a:alpha val="0"/>
+                </a:srgbClr>
+              </a:clrTo>
+            </a:clrChange>
+            <a:extLst>
+              <a:ext uri="{28A0092B-C50C-407E-A947-70E740481C1C}">
+                <a14:useLocalDpi xmlns:a14="http://schemas.microsoft.com/office/drawing/2010/main" val="0"/>
+              </a:ext>
+            </a:extLst>
+          </a:blip>
+          <a:srcRect/>
+          <a:stretch>
+            <a:fillRect/>
+          </a:stretch>
+        </p:blipFill>
+        <p:spPr bwMode="auto">
+          <a:xfrm>
+            <a:off x="2188274" y="1535428"/>
+            <a:ext cx="5447529" cy="3962640"/>
+          </a:xfrm>
+          <a:prstGeom prst="rect">
+            <a:avLst/>
+          </a:prstGeom>
+          <a:noFill/>
+          <a:extLst>
+            <a:ext uri="{909E8E84-426E-40DD-AFC4-6F175D3DCCD1}">
+              <a14:hiddenFill xmlns:a14="http://schemas.microsoft.com/office/drawing/2010/main">
+                <a:solidFill>
+                  <a:srgbClr val="FFFFFF"/>
+                </a:solidFill>
+              </a14:hiddenFill>
+            </a:ext>
+          </a:extLst>
+        </p:spPr>
+      </p:pic>
+    </p:spTree>
+    <p:extLst>
+      <p:ext uri="{BB962C8B-B14F-4D97-AF65-F5344CB8AC3E}">
+        <p14:creationId xmlns:p14="http://schemas.microsoft.com/office/powerpoint/2010/main" val="2287957356"/>
+      </p:ext>
+    </p:extLst>
+  </p:cSld>
+  <p:clrMapOvr>
+    <a:masterClrMapping/>
+  </p:clrMapOvr>
+  <mc:AlternateContent xmlns:mc="http://schemas.openxmlformats.org/markup-compatibility/2006">
+    <mc:Choice xmlns:p14="http://schemas.microsoft.com/office/powerpoint/2010/main" Requires="p14">
+      <p:transition spd="med" p14:dur="700">
+        <p:fade/>
+      </p:transition>
+    </mc:Choice>
+    <mc:Fallback>
+      <p:transition spd="med">
+        <p:fade/>
+      </p:transition>
+    </mc:Fallback>
+  </mc:AlternateContent>
+</p:sld>
+</file>
+
+<file path=ppt/slides/slide23.xml><?xml version="1.0" encoding="utf-8"?>
 <p:sld xmlns:a="http://schemas.openxmlformats.org/drawingml/2006/main" xmlns:r="http://schemas.openxmlformats.org/officeDocument/2006/relationships" xmlns:p="http://schemas.openxmlformats.org/presentationml/2006/main">
   <p:cSld>
     <p:spTree>
@@ -26791,7 +27420,7 @@
 </p:sld>
 </file>
 
-<file path=ppt/slides/slide23.xml><?xml version="1.0" encoding="utf-8"?>
+<file path=ppt/slides/slide24.xml><?xml version="1.0" encoding="utf-8"?>
 <p:sld xmlns:a="http://schemas.openxmlformats.org/drawingml/2006/main" xmlns:r="http://schemas.openxmlformats.org/officeDocument/2006/relationships" xmlns:p="http://schemas.openxmlformats.org/presentationml/2006/main">
   <p:cSld>
     <p:bg>
@@ -27064,7 +27693,7 @@
             <p:ph idx="1"/>
             <p:extLst>
               <p:ext uri="{D42A27DB-BD31-4B8C-83A1-F6EECF244321}">
-                <p14:modId xmlns:p14="http://schemas.microsoft.com/office/powerpoint/2010/main" val="2905772401"/>
+                <p14:modId xmlns:p14="http://schemas.microsoft.com/office/powerpoint/2010/main" val="413561454"/>
               </p:ext>
             </p:extLst>
           </p:nvPr>
@@ -27104,7 +27733,7 @@
 </p:sld>
 </file>
 
-<file path=ppt/slides/slide24.xml><?xml version="1.0" encoding="utf-8"?>
+<file path=ppt/slides/slide25.xml><?xml version="1.0" encoding="utf-8"?>
 <p:sld xmlns:a="http://schemas.openxmlformats.org/drawingml/2006/main" xmlns:r="http://schemas.openxmlformats.org/officeDocument/2006/relationships" xmlns:p="http://schemas.openxmlformats.org/presentationml/2006/main">
   <p:cSld>
     <p:bg>

</xml_diff>